<commit_message>
Rename CY5 blockchain course
</commit_message>
<xml_diff>
--- a/CS_Concentrations.pptx
+++ b/CS_Concentrations.pptx
@@ -8623,7 +8623,7 @@
                 <a:ea typeface="Calibri" pitchFamily="34" charset="-122"/>
                 <a:cs typeface="Calibri" pitchFamily="34" charset="-120"/>
               </a:rPr>
-              <a:t>Blockchain &amp; Decentralized Systems</a:t>
+              <a:t>Blockchain and Decentralized Cryptographic Systems</a:t>
             </a:r>
             <a:endParaRPr lang="en-US" sz="1300" dirty="0"/>
           </a:p>
@@ -12287,7 +12287,7 @@
                 <a:ea typeface="Calibri" pitchFamily="34" charset="-122"/>
                 <a:cs typeface="Calibri" pitchFamily="34" charset="-120"/>
               </a:rPr>
-              <a:t>Blockchain &amp; Decentralized Systems</a:t>
+              <a:t>Blockchain and Decentralized Cryptographic Systems</a:t>
             </a:r>
             <a:endParaRPr lang="en-US" sz="1300" dirty="0"/>
           </a:p>
@@ -17658,7 +17658,7 @@
                 <a:ea typeface="Calibri" pitchFamily="34" charset="-122"/>
                 <a:cs typeface="Calibri" pitchFamily="34" charset="-120"/>
               </a:rPr>
-              <a:t>Blockchain &amp; Decentralized Systems</a:t>
+              <a:t>Blockchain and Decentralized Cryptographic Systems</a:t>
             </a:r>
             <a:endParaRPr lang="en-US" sz="950" dirty="0"/>
           </a:p>

</xml_diff>